<commit_message>
Fix PPTX generation and improve export pipeline
- Strip '#' prefix from hex color codes in PptxRenderer (OpenXML requires
  bare hex values like "8B0000", not "#8B0000")
- Replace blank-template.pptx with PowerPoint COM-generated template that
  includes sldIdLst for proper slide structure
- Route .pptx export through SlideKit instead of Pandoc in export_document
- Add try-catch to GetSlideImage for better error reporting
- Exclude PDB from publish output (SlideKit + MCP)
- Clean stale DLLs from module bin in Build-Deploy.ps1

Co-Authored-By: Claude Opus 4.6 (1M context) <noreply@anthropic.com>
</commit_message>
<xml_diff>
--- a/SlideKit/Rendering/blank-template.pptx
+++ b/SlideKit/Rendering/blank-template.pptx
@@ -4,6 +4,9 @@
   <p:sldMasterIdLst>
     <p:sldMasterId id="2147483648" r:id="rId1"/>
   </p:sldMasterIdLst>
+  <p:sldIdLst>
+    <p:sldId id="256" r:id="rId2"/>
+  </p:sldIdLst>
   <p:sldSz cx="12192000" cy="6858000"/>
   <p:notesSz cx="6858000" cy="9144000"/>
   <p:defaultTextStyle>
@@ -126,7 +129,7 @@
           <p:cNvPr id="2" name="Title 1">
             <a:extLst>
               <a:ext uri="{FF2B5EF4-FFF2-40B4-BE49-F238E27FC236}">
-                <a16:creationId xmlns:a16="http://schemas.microsoft.com/office/drawing/2014/main" id="{E557C878-A8A3-FAAA-57E9-919F3C545673}"/>
+                <a16:creationId xmlns:a16="http://schemas.microsoft.com/office/drawing/2014/main" id="{DA29425F-108E-375E-F0B3-02362F169312}"/>
               </a:ext>
             </a:extLst>
           </p:cNvPr>
@@ -164,7 +167,7 @@
           <p:cNvPr id="3" name="Subtitle 2">
             <a:extLst>
               <a:ext uri="{FF2B5EF4-FFF2-40B4-BE49-F238E27FC236}">
-                <a16:creationId xmlns:a16="http://schemas.microsoft.com/office/drawing/2014/main" id="{A6A44FAF-9E7D-3384-3AF0-F9292970A7AD}"/>
+                <a16:creationId xmlns:a16="http://schemas.microsoft.com/office/drawing/2014/main" id="{73A8EAD4-F84D-FE9A-6FB6-237029063B27}"/>
               </a:ext>
             </a:extLst>
           </p:cNvPr>
@@ -235,7 +238,7 @@
           <p:cNvPr id="4" name="Date Placeholder 3">
             <a:extLst>
               <a:ext uri="{FF2B5EF4-FFF2-40B4-BE49-F238E27FC236}">
-                <a16:creationId xmlns:a16="http://schemas.microsoft.com/office/drawing/2014/main" id="{567DE5AE-4542-9F0F-D74C-C7C1F8C94560}"/>
+                <a16:creationId xmlns:a16="http://schemas.microsoft.com/office/drawing/2014/main" id="{F8E1597B-4FEE-C579-A062-6E232B96ECEC}"/>
               </a:ext>
             </a:extLst>
           </p:cNvPr>
@@ -251,7 +254,7 @@
           <a:bodyPr/>
           <a:lstStyle/>
           <a:p>
-            <a:fld id="{02B9A263-5E0C-45B0-849E-D7BCA5A73EE4}" type="datetimeFigureOut">
+            <a:fld id="{271B6EAC-6790-4DF2-8DED-0C3885C63A4D}" type="datetimeFigureOut">
               <a:rPr kumimoji="1" lang="ja-JP" altLang="en-US" smtClean="0"/>
               <a:t>2026/3/25</a:t>
             </a:fld>
@@ -264,7 +267,7 @@
           <p:cNvPr id="5" name="Footer Placeholder 4">
             <a:extLst>
               <a:ext uri="{FF2B5EF4-FFF2-40B4-BE49-F238E27FC236}">
-                <a16:creationId xmlns:a16="http://schemas.microsoft.com/office/drawing/2014/main" id="{59DD0A76-DD4A-7377-CA7A-AFD7EE1828C4}"/>
+                <a16:creationId xmlns:a16="http://schemas.microsoft.com/office/drawing/2014/main" id="{E2BD6711-0D00-4472-A945-3B148B8FFAE5}"/>
               </a:ext>
             </a:extLst>
           </p:cNvPr>
@@ -289,7 +292,7 @@
           <p:cNvPr id="6" name="Slide Number Placeholder 5">
             <a:extLst>
               <a:ext uri="{FF2B5EF4-FFF2-40B4-BE49-F238E27FC236}">
-                <a16:creationId xmlns:a16="http://schemas.microsoft.com/office/drawing/2014/main" id="{BC09E585-1B73-C02A-3C7E-3DF42FB37110}"/>
+                <a16:creationId xmlns:a16="http://schemas.microsoft.com/office/drawing/2014/main" id="{D6D3C694-102F-A145-C3E5-2BCF73E0368B}"/>
               </a:ext>
             </a:extLst>
           </p:cNvPr>
@@ -305,7 +308,7 @@
           <a:bodyPr/>
           <a:lstStyle/>
           <a:p>
-            <a:fld id="{FAA712C4-5C94-417B-A1DA-CC3205E51DC2}" type="slidenum">
+            <a:fld id="{A75DA1F6-5634-493E-AD06-4F2E3E8892E1}" type="slidenum">
               <a:rPr kumimoji="1" lang="ja-JP" altLang="en-US" smtClean="0"/>
               <a:t>‹#›</a:t>
             </a:fld>
@@ -316,7 +319,7 @@
     </p:spTree>
     <p:extLst>
       <p:ext uri="{BB962C8B-B14F-4D97-AF65-F5344CB8AC3E}">
-        <p14:creationId xmlns:p14="http://schemas.microsoft.com/office/powerpoint/2010/main" val="1801876310"/>
+        <p14:creationId xmlns:p14="http://schemas.microsoft.com/office/powerpoint/2010/main" val="3297887585"/>
       </p:ext>
     </p:extLst>
   </p:cSld>
@@ -348,7 +351,7 @@
           <p:cNvPr id="2" name="Title 1">
             <a:extLst>
               <a:ext uri="{FF2B5EF4-FFF2-40B4-BE49-F238E27FC236}">
-                <a16:creationId xmlns:a16="http://schemas.microsoft.com/office/drawing/2014/main" id="{3AEC596D-1E50-EE72-2D45-4ED46768856B}"/>
+                <a16:creationId xmlns:a16="http://schemas.microsoft.com/office/drawing/2014/main" id="{C61F3F8F-A0B9-1AE6-6092-31728F1ED2E9}"/>
               </a:ext>
             </a:extLst>
           </p:cNvPr>
@@ -377,7 +380,7 @@
           <p:cNvPr id="3" name="Vertical Text Placeholder 2">
             <a:extLst>
               <a:ext uri="{FF2B5EF4-FFF2-40B4-BE49-F238E27FC236}">
-                <a16:creationId xmlns:a16="http://schemas.microsoft.com/office/drawing/2014/main" id="{5DCB2846-3494-BC74-46DF-0AC8F5E5D184}"/>
+                <a16:creationId xmlns:a16="http://schemas.microsoft.com/office/drawing/2014/main" id="{CFB3A8CB-D290-2434-D1C7-12FD596F8903}"/>
               </a:ext>
             </a:extLst>
           </p:cNvPr>
@@ -435,7 +438,7 @@
           <p:cNvPr id="4" name="Date Placeholder 3">
             <a:extLst>
               <a:ext uri="{FF2B5EF4-FFF2-40B4-BE49-F238E27FC236}">
-                <a16:creationId xmlns:a16="http://schemas.microsoft.com/office/drawing/2014/main" id="{8892FC43-DA77-DD09-08A5-F063B6E69231}"/>
+                <a16:creationId xmlns:a16="http://schemas.microsoft.com/office/drawing/2014/main" id="{11AD6D52-827E-4751-4AD9-13C1CF10DAC9}"/>
               </a:ext>
             </a:extLst>
           </p:cNvPr>
@@ -451,7 +454,7 @@
           <a:bodyPr/>
           <a:lstStyle/>
           <a:p>
-            <a:fld id="{02B9A263-5E0C-45B0-849E-D7BCA5A73EE4}" type="datetimeFigureOut">
+            <a:fld id="{271B6EAC-6790-4DF2-8DED-0C3885C63A4D}" type="datetimeFigureOut">
               <a:rPr kumimoji="1" lang="ja-JP" altLang="en-US" smtClean="0"/>
               <a:t>2026/3/25</a:t>
             </a:fld>
@@ -464,7 +467,7 @@
           <p:cNvPr id="5" name="Footer Placeholder 4">
             <a:extLst>
               <a:ext uri="{FF2B5EF4-FFF2-40B4-BE49-F238E27FC236}">
-                <a16:creationId xmlns:a16="http://schemas.microsoft.com/office/drawing/2014/main" id="{47664E4E-553C-3CBB-277F-08F33A73DCB7}"/>
+                <a16:creationId xmlns:a16="http://schemas.microsoft.com/office/drawing/2014/main" id="{33800A54-29FE-3465-15F5-F4F1AD9E8723}"/>
               </a:ext>
             </a:extLst>
           </p:cNvPr>
@@ -489,7 +492,7 @@
           <p:cNvPr id="6" name="Slide Number Placeholder 5">
             <a:extLst>
               <a:ext uri="{FF2B5EF4-FFF2-40B4-BE49-F238E27FC236}">
-                <a16:creationId xmlns:a16="http://schemas.microsoft.com/office/drawing/2014/main" id="{FF607777-BF85-5BB0-71B4-AFD6CF896767}"/>
+                <a16:creationId xmlns:a16="http://schemas.microsoft.com/office/drawing/2014/main" id="{5B981A6C-D048-4396-2EDD-CF3FAF2664F4}"/>
               </a:ext>
             </a:extLst>
           </p:cNvPr>
@@ -505,7 +508,7 @@
           <a:bodyPr/>
           <a:lstStyle/>
           <a:p>
-            <a:fld id="{FAA712C4-5C94-417B-A1DA-CC3205E51DC2}" type="slidenum">
+            <a:fld id="{A75DA1F6-5634-493E-AD06-4F2E3E8892E1}" type="slidenum">
               <a:rPr kumimoji="1" lang="ja-JP" altLang="en-US" smtClean="0"/>
               <a:t>‹#›</a:t>
             </a:fld>
@@ -516,7 +519,7 @@
     </p:spTree>
     <p:extLst>
       <p:ext uri="{BB962C8B-B14F-4D97-AF65-F5344CB8AC3E}">
-        <p14:creationId xmlns:p14="http://schemas.microsoft.com/office/powerpoint/2010/main" val="3480247314"/>
+        <p14:creationId xmlns:p14="http://schemas.microsoft.com/office/powerpoint/2010/main" val="2736128199"/>
       </p:ext>
     </p:extLst>
   </p:cSld>
@@ -548,7 +551,7 @@
           <p:cNvPr id="2" name="Vertical Title 1">
             <a:extLst>
               <a:ext uri="{FF2B5EF4-FFF2-40B4-BE49-F238E27FC236}">
-                <a16:creationId xmlns:a16="http://schemas.microsoft.com/office/drawing/2014/main" id="{E2C276DE-4D4A-97C4-29DE-BFC64B6F134C}"/>
+                <a16:creationId xmlns:a16="http://schemas.microsoft.com/office/drawing/2014/main" id="{2A70EB87-E99D-AA6D-E14D-800D1D92EDA9}"/>
               </a:ext>
             </a:extLst>
           </p:cNvPr>
@@ -582,7 +585,7 @@
           <p:cNvPr id="3" name="Vertical Text Placeholder 2">
             <a:extLst>
               <a:ext uri="{FF2B5EF4-FFF2-40B4-BE49-F238E27FC236}">
-                <a16:creationId xmlns:a16="http://schemas.microsoft.com/office/drawing/2014/main" id="{49B1C016-DB65-2125-09DA-17AFA845AECF}"/>
+                <a16:creationId xmlns:a16="http://schemas.microsoft.com/office/drawing/2014/main" id="{48E6EAF6-9291-B940-9684-D17DB1958EF0}"/>
               </a:ext>
             </a:extLst>
           </p:cNvPr>
@@ -645,7 +648,7 @@
           <p:cNvPr id="4" name="Date Placeholder 3">
             <a:extLst>
               <a:ext uri="{FF2B5EF4-FFF2-40B4-BE49-F238E27FC236}">
-                <a16:creationId xmlns:a16="http://schemas.microsoft.com/office/drawing/2014/main" id="{FB1D7015-F8C4-1F9C-2D89-0EC491CFF995}"/>
+                <a16:creationId xmlns:a16="http://schemas.microsoft.com/office/drawing/2014/main" id="{20A40EEA-D68E-835A-5561-50288BEF1D2A}"/>
               </a:ext>
             </a:extLst>
           </p:cNvPr>
@@ -661,7 +664,7 @@
           <a:bodyPr/>
           <a:lstStyle/>
           <a:p>
-            <a:fld id="{02B9A263-5E0C-45B0-849E-D7BCA5A73EE4}" type="datetimeFigureOut">
+            <a:fld id="{271B6EAC-6790-4DF2-8DED-0C3885C63A4D}" type="datetimeFigureOut">
               <a:rPr kumimoji="1" lang="ja-JP" altLang="en-US" smtClean="0"/>
               <a:t>2026/3/25</a:t>
             </a:fld>
@@ -674,7 +677,7 @@
           <p:cNvPr id="5" name="Footer Placeholder 4">
             <a:extLst>
               <a:ext uri="{FF2B5EF4-FFF2-40B4-BE49-F238E27FC236}">
-                <a16:creationId xmlns:a16="http://schemas.microsoft.com/office/drawing/2014/main" id="{66100F08-91CE-08AF-2A9C-2DA3481B2703}"/>
+                <a16:creationId xmlns:a16="http://schemas.microsoft.com/office/drawing/2014/main" id="{B44B4A69-9465-3DD1-84AD-C040941E5043}"/>
               </a:ext>
             </a:extLst>
           </p:cNvPr>
@@ -699,7 +702,7 @@
           <p:cNvPr id="6" name="Slide Number Placeholder 5">
             <a:extLst>
               <a:ext uri="{FF2B5EF4-FFF2-40B4-BE49-F238E27FC236}">
-                <a16:creationId xmlns:a16="http://schemas.microsoft.com/office/drawing/2014/main" id="{38AD5F2A-B72E-B6A2-C0AD-F5C61ED0D2A5}"/>
+                <a16:creationId xmlns:a16="http://schemas.microsoft.com/office/drawing/2014/main" id="{671C8584-48CE-B7EC-7FCD-7F5D0ED37983}"/>
               </a:ext>
             </a:extLst>
           </p:cNvPr>
@@ -715,7 +718,7 @@
           <a:bodyPr/>
           <a:lstStyle/>
           <a:p>
-            <a:fld id="{FAA712C4-5C94-417B-A1DA-CC3205E51DC2}" type="slidenum">
+            <a:fld id="{A75DA1F6-5634-493E-AD06-4F2E3E8892E1}" type="slidenum">
               <a:rPr kumimoji="1" lang="ja-JP" altLang="en-US" smtClean="0"/>
               <a:t>‹#›</a:t>
             </a:fld>
@@ -726,7 +729,7 @@
     </p:spTree>
     <p:extLst>
       <p:ext uri="{BB962C8B-B14F-4D97-AF65-F5344CB8AC3E}">
-        <p14:creationId xmlns:p14="http://schemas.microsoft.com/office/powerpoint/2010/main" val="1437459677"/>
+        <p14:creationId xmlns:p14="http://schemas.microsoft.com/office/powerpoint/2010/main" val="1470701663"/>
       </p:ext>
     </p:extLst>
   </p:cSld>
@@ -758,7 +761,7 @@
           <p:cNvPr id="2" name="Title 1">
             <a:extLst>
               <a:ext uri="{FF2B5EF4-FFF2-40B4-BE49-F238E27FC236}">
-                <a16:creationId xmlns:a16="http://schemas.microsoft.com/office/drawing/2014/main" id="{4B05C3F8-3A25-C7F8-1F42-474ED01B915F}"/>
+                <a16:creationId xmlns:a16="http://schemas.microsoft.com/office/drawing/2014/main" id="{D7544425-1A28-EDEC-9C71-95C5381941C6}"/>
               </a:ext>
             </a:extLst>
           </p:cNvPr>
@@ -787,7 +790,7 @@
           <p:cNvPr id="3" name="Content Placeholder 2">
             <a:extLst>
               <a:ext uri="{FF2B5EF4-FFF2-40B4-BE49-F238E27FC236}">
-                <a16:creationId xmlns:a16="http://schemas.microsoft.com/office/drawing/2014/main" id="{B8AECC6A-4BC1-D741-5DE9-33EE9DB22098}"/>
+                <a16:creationId xmlns:a16="http://schemas.microsoft.com/office/drawing/2014/main" id="{1196CF38-8BFF-FF7E-5B36-6813C4D167EA}"/>
               </a:ext>
             </a:extLst>
           </p:cNvPr>
@@ -845,7 +848,7 @@
           <p:cNvPr id="4" name="Date Placeholder 3">
             <a:extLst>
               <a:ext uri="{FF2B5EF4-FFF2-40B4-BE49-F238E27FC236}">
-                <a16:creationId xmlns:a16="http://schemas.microsoft.com/office/drawing/2014/main" id="{6E5A280A-4157-2BC3-1376-58068AF87DC7}"/>
+                <a16:creationId xmlns:a16="http://schemas.microsoft.com/office/drawing/2014/main" id="{CD4BBEFF-C305-F572-FA93-DE9857D22E86}"/>
               </a:ext>
             </a:extLst>
           </p:cNvPr>
@@ -861,7 +864,7 @@
           <a:bodyPr/>
           <a:lstStyle/>
           <a:p>
-            <a:fld id="{02B9A263-5E0C-45B0-849E-D7BCA5A73EE4}" type="datetimeFigureOut">
+            <a:fld id="{271B6EAC-6790-4DF2-8DED-0C3885C63A4D}" type="datetimeFigureOut">
               <a:rPr kumimoji="1" lang="ja-JP" altLang="en-US" smtClean="0"/>
               <a:t>2026/3/25</a:t>
             </a:fld>
@@ -874,7 +877,7 @@
           <p:cNvPr id="5" name="Footer Placeholder 4">
             <a:extLst>
               <a:ext uri="{FF2B5EF4-FFF2-40B4-BE49-F238E27FC236}">
-                <a16:creationId xmlns:a16="http://schemas.microsoft.com/office/drawing/2014/main" id="{AB38CC35-E492-01A8-9D90-62770C2E1B4E}"/>
+                <a16:creationId xmlns:a16="http://schemas.microsoft.com/office/drawing/2014/main" id="{F8450DB8-5392-EFFA-098C-B00C599DF6F8}"/>
               </a:ext>
             </a:extLst>
           </p:cNvPr>
@@ -899,7 +902,7 @@
           <p:cNvPr id="6" name="Slide Number Placeholder 5">
             <a:extLst>
               <a:ext uri="{FF2B5EF4-FFF2-40B4-BE49-F238E27FC236}">
-                <a16:creationId xmlns:a16="http://schemas.microsoft.com/office/drawing/2014/main" id="{D492AD93-7F61-B3CB-7D76-39E200AC5C2C}"/>
+                <a16:creationId xmlns:a16="http://schemas.microsoft.com/office/drawing/2014/main" id="{B5918080-751B-0175-020D-E2FAE833ABD9}"/>
               </a:ext>
             </a:extLst>
           </p:cNvPr>
@@ -915,7 +918,7 @@
           <a:bodyPr/>
           <a:lstStyle/>
           <a:p>
-            <a:fld id="{FAA712C4-5C94-417B-A1DA-CC3205E51DC2}" type="slidenum">
+            <a:fld id="{A75DA1F6-5634-493E-AD06-4F2E3E8892E1}" type="slidenum">
               <a:rPr kumimoji="1" lang="ja-JP" altLang="en-US" smtClean="0"/>
               <a:t>‹#›</a:t>
             </a:fld>
@@ -926,7 +929,7 @@
     </p:spTree>
     <p:extLst>
       <p:ext uri="{BB962C8B-B14F-4D97-AF65-F5344CB8AC3E}">
-        <p14:creationId xmlns:p14="http://schemas.microsoft.com/office/powerpoint/2010/main" val="3732937652"/>
+        <p14:creationId xmlns:p14="http://schemas.microsoft.com/office/powerpoint/2010/main" val="1740348828"/>
       </p:ext>
     </p:extLst>
   </p:cSld>
@@ -958,7 +961,7 @@
           <p:cNvPr id="2" name="Title 1">
             <a:extLst>
               <a:ext uri="{FF2B5EF4-FFF2-40B4-BE49-F238E27FC236}">
-                <a16:creationId xmlns:a16="http://schemas.microsoft.com/office/drawing/2014/main" id="{0118127E-B373-F14E-B76D-500B37A80AA6}"/>
+                <a16:creationId xmlns:a16="http://schemas.microsoft.com/office/drawing/2014/main" id="{12FD0733-50D8-7CB2-939F-36377BD015BF}"/>
               </a:ext>
             </a:extLst>
           </p:cNvPr>
@@ -996,7 +999,7 @@
           <p:cNvPr id="3" name="Text Placeholder 2">
             <a:extLst>
               <a:ext uri="{FF2B5EF4-FFF2-40B4-BE49-F238E27FC236}">
-                <a16:creationId xmlns:a16="http://schemas.microsoft.com/office/drawing/2014/main" id="{4B2527ED-9487-6754-8D0D-50A1622143B7}"/>
+                <a16:creationId xmlns:a16="http://schemas.microsoft.com/office/drawing/2014/main" id="{B602E3FF-A81B-C430-8F36-2C4CDDF4C568}"/>
               </a:ext>
             </a:extLst>
           </p:cNvPr>
@@ -1121,7 +1124,7 @@
           <p:cNvPr id="4" name="Date Placeholder 3">
             <a:extLst>
               <a:ext uri="{FF2B5EF4-FFF2-40B4-BE49-F238E27FC236}">
-                <a16:creationId xmlns:a16="http://schemas.microsoft.com/office/drawing/2014/main" id="{704AD227-9976-8195-144C-12B0968AF3F7}"/>
+                <a16:creationId xmlns:a16="http://schemas.microsoft.com/office/drawing/2014/main" id="{0AD79BC8-E5D7-1287-E090-34C8FF3B3C9F}"/>
               </a:ext>
             </a:extLst>
           </p:cNvPr>
@@ -1137,7 +1140,7 @@
           <a:bodyPr/>
           <a:lstStyle/>
           <a:p>
-            <a:fld id="{02B9A263-5E0C-45B0-849E-D7BCA5A73EE4}" type="datetimeFigureOut">
+            <a:fld id="{271B6EAC-6790-4DF2-8DED-0C3885C63A4D}" type="datetimeFigureOut">
               <a:rPr kumimoji="1" lang="ja-JP" altLang="en-US" smtClean="0"/>
               <a:t>2026/3/25</a:t>
             </a:fld>
@@ -1150,7 +1153,7 @@
           <p:cNvPr id="5" name="Footer Placeholder 4">
             <a:extLst>
               <a:ext uri="{FF2B5EF4-FFF2-40B4-BE49-F238E27FC236}">
-                <a16:creationId xmlns:a16="http://schemas.microsoft.com/office/drawing/2014/main" id="{1241AF1E-3C53-4C2A-5936-081BE631AA1B}"/>
+                <a16:creationId xmlns:a16="http://schemas.microsoft.com/office/drawing/2014/main" id="{C2D87C2A-EA52-995D-F520-B9121B9C9098}"/>
               </a:ext>
             </a:extLst>
           </p:cNvPr>
@@ -1175,7 +1178,7 @@
           <p:cNvPr id="6" name="Slide Number Placeholder 5">
             <a:extLst>
               <a:ext uri="{FF2B5EF4-FFF2-40B4-BE49-F238E27FC236}">
-                <a16:creationId xmlns:a16="http://schemas.microsoft.com/office/drawing/2014/main" id="{A1BE6BFD-E795-95E2-2770-1E96E9DD594F}"/>
+                <a16:creationId xmlns:a16="http://schemas.microsoft.com/office/drawing/2014/main" id="{FA4AD9E7-9077-038F-1CD8-A5530197AFF1}"/>
               </a:ext>
             </a:extLst>
           </p:cNvPr>
@@ -1191,7 +1194,7 @@
           <a:bodyPr/>
           <a:lstStyle/>
           <a:p>
-            <a:fld id="{FAA712C4-5C94-417B-A1DA-CC3205E51DC2}" type="slidenum">
+            <a:fld id="{A75DA1F6-5634-493E-AD06-4F2E3E8892E1}" type="slidenum">
               <a:rPr kumimoji="1" lang="ja-JP" altLang="en-US" smtClean="0"/>
               <a:t>‹#›</a:t>
             </a:fld>
@@ -1202,7 +1205,7 @@
     </p:spTree>
     <p:extLst>
       <p:ext uri="{BB962C8B-B14F-4D97-AF65-F5344CB8AC3E}">
-        <p14:creationId xmlns:p14="http://schemas.microsoft.com/office/powerpoint/2010/main" val="2472433757"/>
+        <p14:creationId xmlns:p14="http://schemas.microsoft.com/office/powerpoint/2010/main" val="3720022435"/>
       </p:ext>
     </p:extLst>
   </p:cSld>
@@ -1234,7 +1237,7 @@
           <p:cNvPr id="2" name="Title 1">
             <a:extLst>
               <a:ext uri="{FF2B5EF4-FFF2-40B4-BE49-F238E27FC236}">
-                <a16:creationId xmlns:a16="http://schemas.microsoft.com/office/drawing/2014/main" id="{8A41BBF4-0799-E5CB-5313-53FA110B7A64}"/>
+                <a16:creationId xmlns:a16="http://schemas.microsoft.com/office/drawing/2014/main" id="{990A7636-9C58-27F1-BC5D-7CEBD14AD580}"/>
               </a:ext>
             </a:extLst>
           </p:cNvPr>
@@ -1263,7 +1266,7 @@
           <p:cNvPr id="3" name="Content Placeholder 2">
             <a:extLst>
               <a:ext uri="{FF2B5EF4-FFF2-40B4-BE49-F238E27FC236}">
-                <a16:creationId xmlns:a16="http://schemas.microsoft.com/office/drawing/2014/main" id="{C4E03FDB-8D73-CFF1-721D-A67156F82C39}"/>
+                <a16:creationId xmlns:a16="http://schemas.microsoft.com/office/drawing/2014/main" id="{12D65F7F-A929-1AAF-C11F-2544D5E4CFEE}"/>
               </a:ext>
             </a:extLst>
           </p:cNvPr>
@@ -1326,7 +1329,7 @@
           <p:cNvPr id="4" name="Content Placeholder 3">
             <a:extLst>
               <a:ext uri="{FF2B5EF4-FFF2-40B4-BE49-F238E27FC236}">
-                <a16:creationId xmlns:a16="http://schemas.microsoft.com/office/drawing/2014/main" id="{4DAEE690-24F6-1E9A-FA7A-275311902A4F}"/>
+                <a16:creationId xmlns:a16="http://schemas.microsoft.com/office/drawing/2014/main" id="{D3F7B577-DC25-11B0-3CEB-8BE025EBDE86}"/>
               </a:ext>
             </a:extLst>
           </p:cNvPr>
@@ -1389,7 +1392,7 @@
           <p:cNvPr id="5" name="Date Placeholder 4">
             <a:extLst>
               <a:ext uri="{FF2B5EF4-FFF2-40B4-BE49-F238E27FC236}">
-                <a16:creationId xmlns:a16="http://schemas.microsoft.com/office/drawing/2014/main" id="{05E03101-31C8-C8EB-71EA-B4AA3001CD0E}"/>
+                <a16:creationId xmlns:a16="http://schemas.microsoft.com/office/drawing/2014/main" id="{996E5D4E-B6EE-2251-21B8-7B0FBC509674}"/>
               </a:ext>
             </a:extLst>
           </p:cNvPr>
@@ -1405,7 +1408,7 @@
           <a:bodyPr/>
           <a:lstStyle/>
           <a:p>
-            <a:fld id="{02B9A263-5E0C-45B0-849E-D7BCA5A73EE4}" type="datetimeFigureOut">
+            <a:fld id="{271B6EAC-6790-4DF2-8DED-0C3885C63A4D}" type="datetimeFigureOut">
               <a:rPr kumimoji="1" lang="ja-JP" altLang="en-US" smtClean="0"/>
               <a:t>2026/3/25</a:t>
             </a:fld>
@@ -1418,7 +1421,7 @@
           <p:cNvPr id="6" name="Footer Placeholder 5">
             <a:extLst>
               <a:ext uri="{FF2B5EF4-FFF2-40B4-BE49-F238E27FC236}">
-                <a16:creationId xmlns:a16="http://schemas.microsoft.com/office/drawing/2014/main" id="{C485CB16-68A0-3104-5272-79D81DB088D6}"/>
+                <a16:creationId xmlns:a16="http://schemas.microsoft.com/office/drawing/2014/main" id="{BF6EA52F-CE53-38F7-7B92-07EB89C3849E}"/>
               </a:ext>
             </a:extLst>
           </p:cNvPr>
@@ -1443,7 +1446,7 @@
           <p:cNvPr id="7" name="Slide Number Placeholder 6">
             <a:extLst>
               <a:ext uri="{FF2B5EF4-FFF2-40B4-BE49-F238E27FC236}">
-                <a16:creationId xmlns:a16="http://schemas.microsoft.com/office/drawing/2014/main" id="{26A2D87F-41B3-3C6B-B920-8870D55EB452}"/>
+                <a16:creationId xmlns:a16="http://schemas.microsoft.com/office/drawing/2014/main" id="{986A99E8-627F-5134-4065-54C6E5F4124E}"/>
               </a:ext>
             </a:extLst>
           </p:cNvPr>
@@ -1459,7 +1462,7 @@
           <a:bodyPr/>
           <a:lstStyle/>
           <a:p>
-            <a:fld id="{FAA712C4-5C94-417B-A1DA-CC3205E51DC2}" type="slidenum">
+            <a:fld id="{A75DA1F6-5634-493E-AD06-4F2E3E8892E1}" type="slidenum">
               <a:rPr kumimoji="1" lang="ja-JP" altLang="en-US" smtClean="0"/>
               <a:t>‹#›</a:t>
             </a:fld>
@@ -1470,7 +1473,7 @@
     </p:spTree>
     <p:extLst>
       <p:ext uri="{BB962C8B-B14F-4D97-AF65-F5344CB8AC3E}">
-        <p14:creationId xmlns:p14="http://schemas.microsoft.com/office/powerpoint/2010/main" val="2417024623"/>
+        <p14:creationId xmlns:p14="http://schemas.microsoft.com/office/powerpoint/2010/main" val="3526630530"/>
       </p:ext>
     </p:extLst>
   </p:cSld>
@@ -1502,7 +1505,7 @@
           <p:cNvPr id="2" name="Title 1">
             <a:extLst>
               <a:ext uri="{FF2B5EF4-FFF2-40B4-BE49-F238E27FC236}">
-                <a16:creationId xmlns:a16="http://schemas.microsoft.com/office/drawing/2014/main" id="{68D8D676-F478-5F6B-55D5-37647A4EA398}"/>
+                <a16:creationId xmlns:a16="http://schemas.microsoft.com/office/drawing/2014/main" id="{42479A0F-3464-147A-2029-E8A2E0715A42}"/>
               </a:ext>
             </a:extLst>
           </p:cNvPr>
@@ -1536,7 +1539,7 @@
           <p:cNvPr id="3" name="Text Placeholder 2">
             <a:extLst>
               <a:ext uri="{FF2B5EF4-FFF2-40B4-BE49-F238E27FC236}">
-                <a16:creationId xmlns:a16="http://schemas.microsoft.com/office/drawing/2014/main" id="{D6C361A1-1C50-66FC-2867-447F087350C2}"/>
+                <a16:creationId xmlns:a16="http://schemas.microsoft.com/office/drawing/2014/main" id="{995542DB-8023-9A2C-6205-EEC563F7801C}"/>
               </a:ext>
             </a:extLst>
           </p:cNvPr>
@@ -1607,7 +1610,7 @@
           <p:cNvPr id="4" name="Content Placeholder 3">
             <a:extLst>
               <a:ext uri="{FF2B5EF4-FFF2-40B4-BE49-F238E27FC236}">
-                <a16:creationId xmlns:a16="http://schemas.microsoft.com/office/drawing/2014/main" id="{832C3CFE-5A82-E253-2F80-9D64B9CDA097}"/>
+                <a16:creationId xmlns:a16="http://schemas.microsoft.com/office/drawing/2014/main" id="{6ECE70FB-A889-CDFE-5C8E-C060C00DBBB0}"/>
               </a:ext>
             </a:extLst>
           </p:cNvPr>
@@ -1670,7 +1673,7 @@
           <p:cNvPr id="5" name="Text Placeholder 4">
             <a:extLst>
               <a:ext uri="{FF2B5EF4-FFF2-40B4-BE49-F238E27FC236}">
-                <a16:creationId xmlns:a16="http://schemas.microsoft.com/office/drawing/2014/main" id="{F275D464-577A-671F-8004-858F1F5B4755}"/>
+                <a16:creationId xmlns:a16="http://schemas.microsoft.com/office/drawing/2014/main" id="{93CD661F-F564-24C1-77CB-5EE30BBA2E8F}"/>
               </a:ext>
             </a:extLst>
           </p:cNvPr>
@@ -1741,7 +1744,7 @@
           <p:cNvPr id="6" name="Content Placeholder 5">
             <a:extLst>
               <a:ext uri="{FF2B5EF4-FFF2-40B4-BE49-F238E27FC236}">
-                <a16:creationId xmlns:a16="http://schemas.microsoft.com/office/drawing/2014/main" id="{F2A3D429-520A-B70A-B4D2-8E2136D398C4}"/>
+                <a16:creationId xmlns:a16="http://schemas.microsoft.com/office/drawing/2014/main" id="{8D104CBF-5BE1-B726-2C44-D97C5D2779FC}"/>
               </a:ext>
             </a:extLst>
           </p:cNvPr>
@@ -1804,7 +1807,7 @@
           <p:cNvPr id="7" name="Date Placeholder 6">
             <a:extLst>
               <a:ext uri="{FF2B5EF4-FFF2-40B4-BE49-F238E27FC236}">
-                <a16:creationId xmlns:a16="http://schemas.microsoft.com/office/drawing/2014/main" id="{B0A45481-83FC-8510-BB29-AF2A53760A07}"/>
+                <a16:creationId xmlns:a16="http://schemas.microsoft.com/office/drawing/2014/main" id="{C3D9EC3B-4734-DD85-8ED2-B5949036AE84}"/>
               </a:ext>
             </a:extLst>
           </p:cNvPr>
@@ -1820,7 +1823,7 @@
           <a:bodyPr/>
           <a:lstStyle/>
           <a:p>
-            <a:fld id="{02B9A263-5E0C-45B0-849E-D7BCA5A73EE4}" type="datetimeFigureOut">
+            <a:fld id="{271B6EAC-6790-4DF2-8DED-0C3885C63A4D}" type="datetimeFigureOut">
               <a:rPr kumimoji="1" lang="ja-JP" altLang="en-US" smtClean="0"/>
               <a:t>2026/3/25</a:t>
             </a:fld>
@@ -1833,7 +1836,7 @@
           <p:cNvPr id="8" name="Footer Placeholder 7">
             <a:extLst>
               <a:ext uri="{FF2B5EF4-FFF2-40B4-BE49-F238E27FC236}">
-                <a16:creationId xmlns:a16="http://schemas.microsoft.com/office/drawing/2014/main" id="{7E25706E-0D18-3333-ADE9-F81C31A263FD}"/>
+                <a16:creationId xmlns:a16="http://schemas.microsoft.com/office/drawing/2014/main" id="{2F656CC1-256A-BA1D-4EC6-7D2080C99862}"/>
               </a:ext>
             </a:extLst>
           </p:cNvPr>
@@ -1858,7 +1861,7 @@
           <p:cNvPr id="9" name="Slide Number Placeholder 8">
             <a:extLst>
               <a:ext uri="{FF2B5EF4-FFF2-40B4-BE49-F238E27FC236}">
-                <a16:creationId xmlns:a16="http://schemas.microsoft.com/office/drawing/2014/main" id="{A3026F8C-EE76-4A22-C7C3-933943AFFD07}"/>
+                <a16:creationId xmlns:a16="http://schemas.microsoft.com/office/drawing/2014/main" id="{D1A16B32-7DC3-24A0-8D75-8DC62F03B7FA}"/>
               </a:ext>
             </a:extLst>
           </p:cNvPr>
@@ -1874,7 +1877,7 @@
           <a:bodyPr/>
           <a:lstStyle/>
           <a:p>
-            <a:fld id="{FAA712C4-5C94-417B-A1DA-CC3205E51DC2}" type="slidenum">
+            <a:fld id="{A75DA1F6-5634-493E-AD06-4F2E3E8892E1}" type="slidenum">
               <a:rPr kumimoji="1" lang="ja-JP" altLang="en-US" smtClean="0"/>
               <a:t>‹#›</a:t>
             </a:fld>
@@ -1885,7 +1888,7 @@
     </p:spTree>
     <p:extLst>
       <p:ext uri="{BB962C8B-B14F-4D97-AF65-F5344CB8AC3E}">
-        <p14:creationId xmlns:p14="http://schemas.microsoft.com/office/powerpoint/2010/main" val="3131578370"/>
+        <p14:creationId xmlns:p14="http://schemas.microsoft.com/office/powerpoint/2010/main" val="937095813"/>
       </p:ext>
     </p:extLst>
   </p:cSld>
@@ -1917,7 +1920,7 @@
           <p:cNvPr id="2" name="Title 1">
             <a:extLst>
               <a:ext uri="{FF2B5EF4-FFF2-40B4-BE49-F238E27FC236}">
-                <a16:creationId xmlns:a16="http://schemas.microsoft.com/office/drawing/2014/main" id="{6AAD3D93-7BF9-8769-1A1B-2599A2185218}"/>
+                <a16:creationId xmlns:a16="http://schemas.microsoft.com/office/drawing/2014/main" id="{616123B4-E50E-BD5D-0C81-C5E71F4B448B}"/>
               </a:ext>
             </a:extLst>
           </p:cNvPr>
@@ -1946,7 +1949,7 @@
           <p:cNvPr id="3" name="Date Placeholder 2">
             <a:extLst>
               <a:ext uri="{FF2B5EF4-FFF2-40B4-BE49-F238E27FC236}">
-                <a16:creationId xmlns:a16="http://schemas.microsoft.com/office/drawing/2014/main" id="{EF802E0E-3ADB-F163-62C6-224B873A33D9}"/>
+                <a16:creationId xmlns:a16="http://schemas.microsoft.com/office/drawing/2014/main" id="{96E452F6-093C-5366-A540-A0736B6522CD}"/>
               </a:ext>
             </a:extLst>
           </p:cNvPr>
@@ -1962,7 +1965,7 @@
           <a:bodyPr/>
           <a:lstStyle/>
           <a:p>
-            <a:fld id="{02B9A263-5E0C-45B0-849E-D7BCA5A73EE4}" type="datetimeFigureOut">
+            <a:fld id="{271B6EAC-6790-4DF2-8DED-0C3885C63A4D}" type="datetimeFigureOut">
               <a:rPr kumimoji="1" lang="ja-JP" altLang="en-US" smtClean="0"/>
               <a:t>2026/3/25</a:t>
             </a:fld>
@@ -1975,7 +1978,7 @@
           <p:cNvPr id="4" name="Footer Placeholder 3">
             <a:extLst>
               <a:ext uri="{FF2B5EF4-FFF2-40B4-BE49-F238E27FC236}">
-                <a16:creationId xmlns:a16="http://schemas.microsoft.com/office/drawing/2014/main" id="{A5B4FB61-CB03-2E0F-80E9-C40FBDC3EC2B}"/>
+                <a16:creationId xmlns:a16="http://schemas.microsoft.com/office/drawing/2014/main" id="{383625C4-6F41-6486-A540-7304DEB9C1B4}"/>
               </a:ext>
             </a:extLst>
           </p:cNvPr>
@@ -2000,7 +2003,7 @@
           <p:cNvPr id="5" name="Slide Number Placeholder 4">
             <a:extLst>
               <a:ext uri="{FF2B5EF4-FFF2-40B4-BE49-F238E27FC236}">
-                <a16:creationId xmlns:a16="http://schemas.microsoft.com/office/drawing/2014/main" id="{44FF07C9-08EA-36ED-CFBE-FF44464DA46A}"/>
+                <a16:creationId xmlns:a16="http://schemas.microsoft.com/office/drawing/2014/main" id="{DEE59342-8E2A-03C5-0F68-CFC06C13A6C9}"/>
               </a:ext>
             </a:extLst>
           </p:cNvPr>
@@ -2016,7 +2019,7 @@
           <a:bodyPr/>
           <a:lstStyle/>
           <a:p>
-            <a:fld id="{FAA712C4-5C94-417B-A1DA-CC3205E51DC2}" type="slidenum">
+            <a:fld id="{A75DA1F6-5634-493E-AD06-4F2E3E8892E1}" type="slidenum">
               <a:rPr kumimoji="1" lang="ja-JP" altLang="en-US" smtClean="0"/>
               <a:t>‹#›</a:t>
             </a:fld>
@@ -2027,7 +2030,7 @@
     </p:spTree>
     <p:extLst>
       <p:ext uri="{BB962C8B-B14F-4D97-AF65-F5344CB8AC3E}">
-        <p14:creationId xmlns:p14="http://schemas.microsoft.com/office/powerpoint/2010/main" val="199706127"/>
+        <p14:creationId xmlns:p14="http://schemas.microsoft.com/office/powerpoint/2010/main" val="835232984"/>
       </p:ext>
     </p:extLst>
   </p:cSld>
@@ -2059,7 +2062,7 @@
           <p:cNvPr id="2" name="Date Placeholder 1">
             <a:extLst>
               <a:ext uri="{FF2B5EF4-FFF2-40B4-BE49-F238E27FC236}">
-                <a16:creationId xmlns:a16="http://schemas.microsoft.com/office/drawing/2014/main" id="{A57B7A51-B35C-D074-3C70-8B84B5D90FBA}"/>
+                <a16:creationId xmlns:a16="http://schemas.microsoft.com/office/drawing/2014/main" id="{84AD0F68-0098-BADB-2FBD-DA0A00D88629}"/>
               </a:ext>
             </a:extLst>
           </p:cNvPr>
@@ -2075,7 +2078,7 @@
           <a:bodyPr/>
           <a:lstStyle/>
           <a:p>
-            <a:fld id="{02B9A263-5E0C-45B0-849E-D7BCA5A73EE4}" type="datetimeFigureOut">
+            <a:fld id="{271B6EAC-6790-4DF2-8DED-0C3885C63A4D}" type="datetimeFigureOut">
               <a:rPr kumimoji="1" lang="ja-JP" altLang="en-US" smtClean="0"/>
               <a:t>2026/3/25</a:t>
             </a:fld>
@@ -2088,7 +2091,7 @@
           <p:cNvPr id="3" name="Footer Placeholder 2">
             <a:extLst>
               <a:ext uri="{FF2B5EF4-FFF2-40B4-BE49-F238E27FC236}">
-                <a16:creationId xmlns:a16="http://schemas.microsoft.com/office/drawing/2014/main" id="{078D7423-95B3-60A0-5780-8D8180943B40}"/>
+                <a16:creationId xmlns:a16="http://schemas.microsoft.com/office/drawing/2014/main" id="{E26FA1BD-FEBE-2755-F9CF-38181B601AEE}"/>
               </a:ext>
             </a:extLst>
           </p:cNvPr>
@@ -2113,7 +2116,7 @@
           <p:cNvPr id="4" name="Slide Number Placeholder 3">
             <a:extLst>
               <a:ext uri="{FF2B5EF4-FFF2-40B4-BE49-F238E27FC236}">
-                <a16:creationId xmlns:a16="http://schemas.microsoft.com/office/drawing/2014/main" id="{5E91B0B9-DC7E-04DC-D5C7-6812261494B5}"/>
+                <a16:creationId xmlns:a16="http://schemas.microsoft.com/office/drawing/2014/main" id="{F6A50B7A-8A51-7F47-F3F3-9DFAFBDA89B3}"/>
               </a:ext>
             </a:extLst>
           </p:cNvPr>
@@ -2129,7 +2132,7 @@
           <a:bodyPr/>
           <a:lstStyle/>
           <a:p>
-            <a:fld id="{FAA712C4-5C94-417B-A1DA-CC3205E51DC2}" type="slidenum">
+            <a:fld id="{A75DA1F6-5634-493E-AD06-4F2E3E8892E1}" type="slidenum">
               <a:rPr kumimoji="1" lang="ja-JP" altLang="en-US" smtClean="0"/>
               <a:t>‹#›</a:t>
             </a:fld>
@@ -2140,7 +2143,7 @@
     </p:spTree>
     <p:extLst>
       <p:ext uri="{BB962C8B-B14F-4D97-AF65-F5344CB8AC3E}">
-        <p14:creationId xmlns:p14="http://schemas.microsoft.com/office/powerpoint/2010/main" val="718748729"/>
+        <p14:creationId xmlns:p14="http://schemas.microsoft.com/office/powerpoint/2010/main" val="3839566821"/>
       </p:ext>
     </p:extLst>
   </p:cSld>
@@ -2172,7 +2175,7 @@
           <p:cNvPr id="2" name="Title 1">
             <a:extLst>
               <a:ext uri="{FF2B5EF4-FFF2-40B4-BE49-F238E27FC236}">
-                <a16:creationId xmlns:a16="http://schemas.microsoft.com/office/drawing/2014/main" id="{CC6DC06A-C621-0648-718F-67675F2D5510}"/>
+                <a16:creationId xmlns:a16="http://schemas.microsoft.com/office/drawing/2014/main" id="{03AF9037-8D50-6229-14E5-94615BE5ABA0}"/>
               </a:ext>
             </a:extLst>
           </p:cNvPr>
@@ -2210,7 +2213,7 @@
           <p:cNvPr id="3" name="Content Placeholder 2">
             <a:extLst>
               <a:ext uri="{FF2B5EF4-FFF2-40B4-BE49-F238E27FC236}">
-                <a16:creationId xmlns:a16="http://schemas.microsoft.com/office/drawing/2014/main" id="{098D825C-BD03-4E26-2745-68541D3627E2}"/>
+                <a16:creationId xmlns:a16="http://schemas.microsoft.com/office/drawing/2014/main" id="{4E542FEC-0FDD-E443-5556-A2AD30F964EF}"/>
               </a:ext>
             </a:extLst>
           </p:cNvPr>
@@ -2301,7 +2304,7 @@
           <p:cNvPr id="4" name="Text Placeholder 3">
             <a:extLst>
               <a:ext uri="{FF2B5EF4-FFF2-40B4-BE49-F238E27FC236}">
-                <a16:creationId xmlns:a16="http://schemas.microsoft.com/office/drawing/2014/main" id="{785C42D8-E770-1C53-BCE2-354DC143BB47}"/>
+                <a16:creationId xmlns:a16="http://schemas.microsoft.com/office/drawing/2014/main" id="{4DD242E7-0E72-FB06-8578-585B1C9A11B5}"/>
               </a:ext>
             </a:extLst>
           </p:cNvPr>
@@ -2372,7 +2375,7 @@
           <p:cNvPr id="5" name="Date Placeholder 4">
             <a:extLst>
               <a:ext uri="{FF2B5EF4-FFF2-40B4-BE49-F238E27FC236}">
-                <a16:creationId xmlns:a16="http://schemas.microsoft.com/office/drawing/2014/main" id="{59853EA1-22EF-F059-03FC-4E1B41ACEB06}"/>
+                <a16:creationId xmlns:a16="http://schemas.microsoft.com/office/drawing/2014/main" id="{B8FCEE1A-66C9-E077-1C63-ABB569D53BCF}"/>
               </a:ext>
             </a:extLst>
           </p:cNvPr>
@@ -2388,7 +2391,7 @@
           <a:bodyPr/>
           <a:lstStyle/>
           <a:p>
-            <a:fld id="{02B9A263-5E0C-45B0-849E-D7BCA5A73EE4}" type="datetimeFigureOut">
+            <a:fld id="{271B6EAC-6790-4DF2-8DED-0C3885C63A4D}" type="datetimeFigureOut">
               <a:rPr kumimoji="1" lang="ja-JP" altLang="en-US" smtClean="0"/>
               <a:t>2026/3/25</a:t>
             </a:fld>
@@ -2401,7 +2404,7 @@
           <p:cNvPr id="6" name="Footer Placeholder 5">
             <a:extLst>
               <a:ext uri="{FF2B5EF4-FFF2-40B4-BE49-F238E27FC236}">
-                <a16:creationId xmlns:a16="http://schemas.microsoft.com/office/drawing/2014/main" id="{2BB74A9D-5025-C426-A6CD-470273143966}"/>
+                <a16:creationId xmlns:a16="http://schemas.microsoft.com/office/drawing/2014/main" id="{B680A0A2-10BE-6387-5BD9-BA460179651B}"/>
               </a:ext>
             </a:extLst>
           </p:cNvPr>
@@ -2426,7 +2429,7 @@
           <p:cNvPr id="7" name="Slide Number Placeholder 6">
             <a:extLst>
               <a:ext uri="{FF2B5EF4-FFF2-40B4-BE49-F238E27FC236}">
-                <a16:creationId xmlns:a16="http://schemas.microsoft.com/office/drawing/2014/main" id="{8C29A330-E46E-0C6A-B88C-D08943F8F660}"/>
+                <a16:creationId xmlns:a16="http://schemas.microsoft.com/office/drawing/2014/main" id="{A293FD03-6566-44CA-21BC-1AB059BBF15F}"/>
               </a:ext>
             </a:extLst>
           </p:cNvPr>
@@ -2442,7 +2445,7 @@
           <a:bodyPr/>
           <a:lstStyle/>
           <a:p>
-            <a:fld id="{FAA712C4-5C94-417B-A1DA-CC3205E51DC2}" type="slidenum">
+            <a:fld id="{A75DA1F6-5634-493E-AD06-4F2E3E8892E1}" type="slidenum">
               <a:rPr kumimoji="1" lang="ja-JP" altLang="en-US" smtClean="0"/>
               <a:t>‹#›</a:t>
             </a:fld>
@@ -2453,7 +2456,7 @@
     </p:spTree>
     <p:extLst>
       <p:ext uri="{BB962C8B-B14F-4D97-AF65-F5344CB8AC3E}">
-        <p14:creationId xmlns:p14="http://schemas.microsoft.com/office/powerpoint/2010/main" val="3305899890"/>
+        <p14:creationId xmlns:p14="http://schemas.microsoft.com/office/powerpoint/2010/main" val="3663536902"/>
       </p:ext>
     </p:extLst>
   </p:cSld>
@@ -2485,7 +2488,7 @@
           <p:cNvPr id="2" name="Title 1">
             <a:extLst>
               <a:ext uri="{FF2B5EF4-FFF2-40B4-BE49-F238E27FC236}">
-                <a16:creationId xmlns:a16="http://schemas.microsoft.com/office/drawing/2014/main" id="{A1684ABA-872D-F9EE-AD22-A8E9391728F1}"/>
+                <a16:creationId xmlns:a16="http://schemas.microsoft.com/office/drawing/2014/main" id="{101009DE-6164-6757-7A46-C62687F71C35}"/>
               </a:ext>
             </a:extLst>
           </p:cNvPr>
@@ -2523,7 +2526,7 @@
           <p:cNvPr id="3" name="Picture Placeholder 2">
             <a:extLst>
               <a:ext uri="{FF2B5EF4-FFF2-40B4-BE49-F238E27FC236}">
-                <a16:creationId xmlns:a16="http://schemas.microsoft.com/office/drawing/2014/main" id="{DA087870-95E5-189F-A31A-EFF04DD44B26}"/>
+                <a16:creationId xmlns:a16="http://schemas.microsoft.com/office/drawing/2014/main" id="{EA6E544F-3C01-ECF1-346E-A52CD977A787}"/>
               </a:ext>
             </a:extLst>
           </p:cNvPr>
@@ -2590,7 +2593,7 @@
           <p:cNvPr id="4" name="Text Placeholder 3">
             <a:extLst>
               <a:ext uri="{FF2B5EF4-FFF2-40B4-BE49-F238E27FC236}">
-                <a16:creationId xmlns:a16="http://schemas.microsoft.com/office/drawing/2014/main" id="{D04AD0ED-1791-04D3-372D-92268B04CECF}"/>
+                <a16:creationId xmlns:a16="http://schemas.microsoft.com/office/drawing/2014/main" id="{F3F49EC0-16F9-9FEC-E004-6CFEF73EC807}"/>
               </a:ext>
             </a:extLst>
           </p:cNvPr>
@@ -2661,7 +2664,7 @@
           <p:cNvPr id="5" name="Date Placeholder 4">
             <a:extLst>
               <a:ext uri="{FF2B5EF4-FFF2-40B4-BE49-F238E27FC236}">
-                <a16:creationId xmlns:a16="http://schemas.microsoft.com/office/drawing/2014/main" id="{69442801-2E28-D323-E64D-DEDB021FC5D7}"/>
+                <a16:creationId xmlns:a16="http://schemas.microsoft.com/office/drawing/2014/main" id="{E149615F-DDE8-8545-EFAE-02EBF195F7D1}"/>
               </a:ext>
             </a:extLst>
           </p:cNvPr>
@@ -2677,7 +2680,7 @@
           <a:bodyPr/>
           <a:lstStyle/>
           <a:p>
-            <a:fld id="{02B9A263-5E0C-45B0-849E-D7BCA5A73EE4}" type="datetimeFigureOut">
+            <a:fld id="{271B6EAC-6790-4DF2-8DED-0C3885C63A4D}" type="datetimeFigureOut">
               <a:rPr kumimoji="1" lang="ja-JP" altLang="en-US" smtClean="0"/>
               <a:t>2026/3/25</a:t>
             </a:fld>
@@ -2690,7 +2693,7 @@
           <p:cNvPr id="6" name="Footer Placeholder 5">
             <a:extLst>
               <a:ext uri="{FF2B5EF4-FFF2-40B4-BE49-F238E27FC236}">
-                <a16:creationId xmlns:a16="http://schemas.microsoft.com/office/drawing/2014/main" id="{C281C7AF-C584-185F-F68B-4BE688F4EC1A}"/>
+                <a16:creationId xmlns:a16="http://schemas.microsoft.com/office/drawing/2014/main" id="{6B8FA89E-7269-873C-2628-7A2186F0EB7B}"/>
               </a:ext>
             </a:extLst>
           </p:cNvPr>
@@ -2715,7 +2718,7 @@
           <p:cNvPr id="7" name="Slide Number Placeholder 6">
             <a:extLst>
               <a:ext uri="{FF2B5EF4-FFF2-40B4-BE49-F238E27FC236}">
-                <a16:creationId xmlns:a16="http://schemas.microsoft.com/office/drawing/2014/main" id="{485D5908-B3BA-403D-A931-D0E27623FEAC}"/>
+                <a16:creationId xmlns:a16="http://schemas.microsoft.com/office/drawing/2014/main" id="{674A30E8-3CC1-15D4-D9EA-38148AF374C7}"/>
               </a:ext>
             </a:extLst>
           </p:cNvPr>
@@ -2731,7 +2734,7 @@
           <a:bodyPr/>
           <a:lstStyle/>
           <a:p>
-            <a:fld id="{FAA712C4-5C94-417B-A1DA-CC3205E51DC2}" type="slidenum">
+            <a:fld id="{A75DA1F6-5634-493E-AD06-4F2E3E8892E1}" type="slidenum">
               <a:rPr kumimoji="1" lang="ja-JP" altLang="en-US" smtClean="0"/>
               <a:t>‹#›</a:t>
             </a:fld>
@@ -2742,7 +2745,7 @@
     </p:spTree>
     <p:extLst>
       <p:ext uri="{BB962C8B-B14F-4D97-AF65-F5344CB8AC3E}">
-        <p14:creationId xmlns:p14="http://schemas.microsoft.com/office/powerpoint/2010/main" val="650727536"/>
+        <p14:creationId xmlns:p14="http://schemas.microsoft.com/office/powerpoint/2010/main" val="1096437722"/>
       </p:ext>
     </p:extLst>
   </p:cSld>
@@ -2779,7 +2782,7 @@
           <p:cNvPr id="2" name="Title Placeholder 1">
             <a:extLst>
               <a:ext uri="{FF2B5EF4-FFF2-40B4-BE49-F238E27FC236}">
-                <a16:creationId xmlns:a16="http://schemas.microsoft.com/office/drawing/2014/main" id="{9DCBE078-69F8-C8B5-D044-BC13C366025B}"/>
+                <a16:creationId xmlns:a16="http://schemas.microsoft.com/office/drawing/2014/main" id="{95F1E473-4E11-F1BD-8461-86887C75AC6F}"/>
               </a:ext>
             </a:extLst>
           </p:cNvPr>
@@ -2818,7 +2821,7 @@
           <p:cNvPr id="3" name="Text Placeholder 2">
             <a:extLst>
               <a:ext uri="{FF2B5EF4-FFF2-40B4-BE49-F238E27FC236}">
-                <a16:creationId xmlns:a16="http://schemas.microsoft.com/office/drawing/2014/main" id="{5909A6F3-1858-95AA-9724-C1ECB59D1162}"/>
+                <a16:creationId xmlns:a16="http://schemas.microsoft.com/office/drawing/2014/main" id="{F8DEDE19-C0FF-E4DC-EC04-D72319AA4E34}"/>
               </a:ext>
             </a:extLst>
           </p:cNvPr>
@@ -2886,7 +2889,7 @@
           <p:cNvPr id="4" name="Date Placeholder 3">
             <a:extLst>
               <a:ext uri="{FF2B5EF4-FFF2-40B4-BE49-F238E27FC236}">
-                <a16:creationId xmlns:a16="http://schemas.microsoft.com/office/drawing/2014/main" id="{329BB553-4886-4907-F47C-D80ECF7092D7}"/>
+                <a16:creationId xmlns:a16="http://schemas.microsoft.com/office/drawing/2014/main" id="{3BEA1861-3B8B-F5FE-C0AD-6CF0B60CB0EA}"/>
               </a:ext>
             </a:extLst>
           </p:cNvPr>
@@ -2920,7 +2923,7 @@
             </a:lvl1pPr>
           </a:lstStyle>
           <a:p>
-            <a:fld id="{02B9A263-5E0C-45B0-849E-D7BCA5A73EE4}" type="datetimeFigureOut">
+            <a:fld id="{271B6EAC-6790-4DF2-8DED-0C3885C63A4D}" type="datetimeFigureOut">
               <a:rPr kumimoji="1" lang="ja-JP" altLang="en-US" smtClean="0"/>
               <a:t>2026/3/25</a:t>
             </a:fld>
@@ -2933,7 +2936,7 @@
           <p:cNvPr id="5" name="Footer Placeholder 4">
             <a:extLst>
               <a:ext uri="{FF2B5EF4-FFF2-40B4-BE49-F238E27FC236}">
-                <a16:creationId xmlns:a16="http://schemas.microsoft.com/office/drawing/2014/main" id="{8D17DC98-B61C-5546-A9F2-77F6952CAB32}"/>
+                <a16:creationId xmlns:a16="http://schemas.microsoft.com/office/drawing/2014/main" id="{FBDDFDCF-0A4C-D9F6-9B62-513A6F54E45F}"/>
               </a:ext>
             </a:extLst>
           </p:cNvPr>
@@ -2976,7 +2979,7 @@
           <p:cNvPr id="6" name="Slide Number Placeholder 5">
             <a:extLst>
               <a:ext uri="{FF2B5EF4-FFF2-40B4-BE49-F238E27FC236}">
-                <a16:creationId xmlns:a16="http://schemas.microsoft.com/office/drawing/2014/main" id="{51AE8CB1-A303-7FBD-90EA-A0D0A4ABC82E}"/>
+                <a16:creationId xmlns:a16="http://schemas.microsoft.com/office/drawing/2014/main" id="{1EFC77F8-2B5A-432F-7DA2-5D491521772F}"/>
               </a:ext>
             </a:extLst>
           </p:cNvPr>
@@ -3010,7 +3013,7 @@
             </a:lvl1pPr>
           </a:lstStyle>
           <a:p>
-            <a:fld id="{FAA712C4-5C94-417B-A1DA-CC3205E51DC2}" type="slidenum">
+            <a:fld id="{A75DA1F6-5634-493E-AD06-4F2E3E8892E1}" type="slidenum">
               <a:rPr kumimoji="1" lang="ja-JP" altLang="en-US" smtClean="0"/>
               <a:t>‹#›</a:t>
             </a:fld>
@@ -3021,7 +3024,7 @@
     </p:spTree>
     <p:extLst>
       <p:ext uri="{BB962C8B-B14F-4D97-AF65-F5344CB8AC3E}">
-        <p14:creationId xmlns:p14="http://schemas.microsoft.com/office/powerpoint/2010/main" val="1220398361"/>
+        <p14:creationId xmlns:p14="http://schemas.microsoft.com/office/powerpoint/2010/main" val="2188369554"/>
       </p:ext>
     </p:extLst>
   </p:cSld>
@@ -3320,6 +3323,36 @@
     </p:otherStyle>
   </p:txStyles>
 </p:sldMaster>
+</file>
+
+<file path=ppt/slides/slide1.xml><?xml version="1.0" encoding="utf-8"?>
+<p:sld xmlns:a="http://schemas.openxmlformats.org/drawingml/2006/main" xmlns:r="http://schemas.openxmlformats.org/officeDocument/2006/relationships" xmlns:p="http://schemas.openxmlformats.org/presentationml/2006/main">
+  <p:cSld>
+    <p:spTree>
+      <p:nvGrpSpPr>
+        <p:cNvPr id="1" name=""/>
+        <p:cNvGrpSpPr/>
+        <p:nvPr/>
+      </p:nvGrpSpPr>
+      <p:grpSpPr>
+        <a:xfrm>
+          <a:off x="0" y="0"/>
+          <a:ext cx="0" cy="0"/>
+          <a:chOff x="0" y="0"/>
+          <a:chExt cx="0" cy="0"/>
+        </a:xfrm>
+      </p:grpSpPr>
+    </p:spTree>
+    <p:extLst>
+      <p:ext uri="{BB962C8B-B14F-4D97-AF65-F5344CB8AC3E}">
+        <p14:creationId xmlns:p14="http://schemas.microsoft.com/office/powerpoint/2010/main" val="1358582027"/>
+      </p:ext>
+    </p:extLst>
+  </p:cSld>
+  <p:clrMapOvr>
+    <a:masterClrMapping/>
+  </p:clrMapOvr>
+</p:sld>
 </file>
 
 <file path=ppt/theme/theme1.xml><?xml version="1.0" encoding="utf-8"?>

</xml_diff>